<commit_message>
Document the deployed MLP policy only; keep Cartan in the dedicated copy repo.
Co-authored-by: Cursor <cursoragent@cursor.com>
</commit_message>
<xml_diff>
--- a/docs/architecture-integration.pptx
+++ b/docs/architecture-integration.pptx
@@ -3826,7 +3826,7 @@
                             <a:srgbClr val="202020"/>
                           </a:solidFill>
                         </a:rPr>
-                        <a:t>policy_*.h in C, 0.3 ms on the Mac</a:t>
+                        <a:t>policy_mlp.h in C, 0.37 ms on the Mac</a:t>
                       </a:r>
                     </a:p>
                   </a:txBody>
@@ -3847,7 +3847,7 @@
                             <a:srgbClr val="202020"/>
                           </a:solidFill>
                         </a:rPr>
-                        <a:t>same source; STM32H7: 1–2 ms estimated (MLP), Cartan to be measured</a:t>
+                        <a:t>same source; STM32H7: 1–2 ms estimated (MLP)</a:t>
                       </a:r>
                     </a:p>
                   </a:txBody>
@@ -4190,7 +4190,7 @@
             </a:pPr>
             <a:r>
               <a:rPr sz="1200" b="0"/>
-              <a:t>•  param set MDK_POLICY 0|1 · param set MDK_ENABLE 1</a:t>
+              <a:t>•  param set MDK_POLICY 0 · param set MDK_ENABLE 1</a:t>
             </a:r>
           </a:p>
           <a:p>
@@ -4306,9 +4306,8 @@
                 <a:tableStyleId>{5C22544A-7EE6-4342-B048-85BDC9FD1C3A}</a:tableStyleId>
               </a:tblPr>
               <a:tblGrid>
-                <a:gridCol w="2560320"/>
-                <a:gridCol w="1371600"/>
-                <a:gridCol w="1371600"/>
+                <a:gridCol w="3200400"/>
+                <a:gridCol w="2103120"/>
               </a:tblGrid>
               <a:tr h="411480">
                 <a:tc>
@@ -4344,27 +4343,6 @@
                           </a:solidFill>
                         </a:rPr>
                         <a:t>MLP</a:t>
-                      </a:r>
-                    </a:p>
-                  </a:txBody>
-                  <a:tcPr>
-                    <a:solidFill>
-                      <a:srgbClr val="0D3B66"/>
-                    </a:solidFill>
-                  </a:tcPr>
-                </a:tc>
-                <a:tc>
-                  <a:txBody>
-                    <a:bodyPr/>
-                    <a:lstStyle/>
-                    <a:p>
-                      <a:r>
-                        <a:rPr sz="1200" b="1">
-                          <a:solidFill>
-                            <a:srgbClr val="FFFFFF"/>
-                          </a:solidFill>
-                        </a:rPr>
-                        <a:t>Cartan</a:t>
                       </a:r>
                     </a:p>
                   </a:txBody>
@@ -4418,27 +4396,6 @@
                     </a:solidFill>
                   </a:tcPr>
                 </a:tc>
-                <a:tc>
-                  <a:txBody>
-                    <a:bodyPr/>
-                    <a:lstStyle/>
-                    <a:p>
-                      <a:r>
-                        <a:rPr sz="1200" b="0">
-                          <a:solidFill>
-                            <a:srgbClr val="202020"/>
-                          </a:solidFill>
-                        </a:rPr>
-                        <a:t>6.0e-5</a:t>
-                      </a:r>
-                    </a:p>
-                  </a:txBody>
-                  <a:tcPr>
-                    <a:solidFill>
-                      <a:srgbClr val="FFFFFF"/>
-                    </a:solidFill>
-                  </a:tcPr>
-                </a:tc>
               </a:tr>
               <a:tr h="411480">
                 <a:tc>
@@ -4474,27 +4431,6 @@
                           </a:solidFill>
                         </a:rPr>
                         <a:t>2.5e-7</a:t>
-                      </a:r>
-                    </a:p>
-                  </a:txBody>
-                  <a:tcPr>
-                    <a:solidFill>
-                      <a:srgbClr val="F4F7FB"/>
-                    </a:solidFill>
-                  </a:tcPr>
-                </a:tc>
-                <a:tc>
-                  <a:txBody>
-                    <a:bodyPr/>
-                    <a:lstStyle/>
-                    <a:p>
-                      <a:r>
-                        <a:rPr sz="1200" b="0">
-                          <a:solidFill>
-                            <a:srgbClr val="202020"/>
-                          </a:solidFill>
-                        </a:rPr>
-                        <a:t>1.3e-6 (p99)</a:t>
                       </a:r>
                     </a:p>
                   </a:txBody>
@@ -4548,27 +4484,6 @@
                     </a:solidFill>
                   </a:tcPr>
                 </a:tc>
-                <a:tc>
-                  <a:txBody>
-                    <a:bodyPr/>
-                    <a:lstStyle/>
-                    <a:p>
-                      <a:r>
-                        <a:rPr sz="1200" b="0">
-                          <a:solidFill>
-                            <a:srgbClr val="202020"/>
-                          </a:solidFill>
-                        </a:rPr>
-                        <a:t>0.25 ms</a:t>
-                      </a:r>
-                    </a:p>
-                  </a:txBody>
-                  <a:tcPr>
-                    <a:solidFill>
-                      <a:srgbClr val="FFFFFF"/>
-                    </a:solidFill>
-                  </a:tcPr>
-                </a:tc>
               </a:tr>
               <a:tr h="411480">
                 <a:tc>
@@ -4613,27 +4528,6 @@
                     </a:solidFill>
                   </a:tcPr>
                 </a:tc>
-                <a:tc>
-                  <a:txBody>
-                    <a:bodyPr/>
-                    <a:lstStyle/>
-                    <a:p>
-                      <a:r>
-                        <a:rPr sz="1200" b="0">
-                          <a:solidFill>
-                            <a:srgbClr val="202020"/>
-                          </a:solidFill>
-                        </a:rPr>
-                        <a:t>496 KB</a:t>
-                      </a:r>
-                    </a:p>
-                  </a:txBody>
-                  <a:tcPr>
-                    <a:solidFill>
-                      <a:srgbClr val="F4F7FB"/>
-                    </a:solidFill>
-                  </a:tcPr>
-                </a:tc>
               </a:tr>
               <a:tr h="411480">
                 <a:tc>
@@ -4648,27 +4542,6 @@
                           </a:solidFill>
                         </a:rPr>
                         <a:t>HIL battery, 8 steps</a:t>
-                      </a:r>
-                    </a:p>
-                  </a:txBody>
-                  <a:tcPr>
-                    <a:solidFill>
-                      <a:srgbClr val="FFFFFF"/>
-                    </a:solidFill>
-                  </a:tcPr>
-                </a:tc>
-                <a:tc>
-                  <a:txBody>
-                    <a:bodyPr/>
-                    <a:lstStyle/>
-                    <a:p>
-                      <a:r>
-                        <a:rPr sz="1200" b="0">
-                          <a:solidFill>
-                            <a:srgbClr val="202020"/>
-                          </a:solidFill>
-                        </a:rPr>
-                        <a:t>8/8 PASS</a:t>
                       </a:r>
                     </a:p>
                   </a:txBody>
@@ -4743,27 +4616,6 @@
                     </a:solidFill>
                   </a:tcPr>
                 </a:tc>
-                <a:tc>
-                  <a:txBody>
-                    <a:bodyPr/>
-                    <a:lstStyle/>
-                    <a:p>
-                      <a:r>
-                        <a:rPr sz="1200" b="0">
-                          <a:solidFill>
-                            <a:srgbClr val="202020"/>
-                          </a:solidFill>
-                        </a:rPr>
-                        <a:t>—</a:t>
-                      </a:r>
-                    </a:p>
-                  </a:txBody>
-                  <a:tcPr>
-                    <a:solidFill>
-                      <a:srgbClr val="F4F7FB"/>
-                    </a:solidFill>
-                  </a:tcPr>
-                </a:tc>
               </a:tr>
             </a:tbl>
           </a:graphicData>
@@ -6403,7 +6255,7 @@
                   <a:srgbClr val="0D3B66"/>
                 </a:solidFill>
               </a:rPr>
-              <a:t>MLP | Cartan</a:t>
+              <a:t>MLP</a:t>
             </a:r>
           </a:p>
           <a:p>
@@ -6414,7 +6266,7 @@
                   <a:srgbClr val="0D3B66"/>
                 </a:solidFill>
               </a:rPr>
-              <a:t>≈0.3 ms</a:t>
+              <a:t>≈0.37 ms</a:t>
             </a:r>
           </a:p>
         </p:txBody>
@@ -8371,7 +8223,7 @@
                             <a:srgbClr val="202020"/>
                           </a:solidFill>
                         </a:rPr>
-                        <a:t>param set MDK_POLICY 1</a:t>
+                        <a:t>param set MDK_POLICY 0</a:t>
                       </a:r>
                     </a:p>
                   </a:txBody>
@@ -8434,7 +8286,7 @@
                             <a:srgbClr val="202020"/>
                           </a:solidFill>
                         </a:rPr>
-                        <a:t>next tick uses the Cartan network</a:t>
+                        <a:t>next tick uses the MLP network</a:t>
                       </a:r>
                     </a:p>
                   </a:txBody>
@@ -9561,7 +9413,7 @@
                             <a:srgbClr val="202020"/>
                           </a:solidFill>
                         </a:rPr>
-                        <a:t>AP_MicroDuck.{h,cpp}, microduck_infer.{h,c}, policy_mlp.h, policy_cartan.h, AP_MicroDuck_config.h</a:t>
+                        <a:t>AP_MicroDuck.{h,cpp}, microduck_infer.{h,c}, policy_mlp.h, AP_MicroDuck_config.h</a:t>
                       </a:r>
                     </a:p>
                   </a:txBody>
@@ -9947,7 +9799,7 @@
             <a:pPr algn="l"/>
             <a:r>
               <a:rPr sz="1300" b="0"/>
-              <a:t>No change to RC_Channels, SRV_Channel, AP_InertialSensor, AP_Arming, GCS_MAVLink: the task uses their public APIs. AP_MICRODUCK_ENABLED is 1 on SITL; boards must opt in (weights ~770 KB + ~500 KB of flash as float32).</a:t>
+              <a:t>No change to RC_Channels, SRV_Channel, AP_InertialSensor, AP_Arming, GCS_MAVLink: the task uses their public APIs. AP_MICRODUCK_ENABLED is 1 on SITL; boards must opt in (weights ~770 KB of flash as float32).</a:t>
             </a:r>
           </a:p>
           <a:p>
@@ -16290,7 +16142,7 @@
             </a:pPr>
             <a:r>
               <a:rPr sz="1200" b="0"/>
-              <a:t>•  The 50 Hz task sees 4 physics steps per action, as in training (decimation 4). The forward pass takes 0.25–0.37 ms on the Mac; 1–2 ms estimated on an STM32H7.</a:t>
+              <a:t>•  The 50 Hz task sees 4 physics steps per action, as in training (decimation 4). The forward pass takes ~0.37 ms on the Mac; 1–2 ms estimated on an STM32H7.</a:t>
             </a:r>
           </a:p>
         </p:txBody>
@@ -16651,7 +16503,7 @@
                   <a:srgbClr val="0D3B66"/>
                 </a:solidFill>
               </a:rPr>
-              <a:t>Gemm/ELU… or Cartan</a:t>
+              <a:t>Gemm/ELU</a:t>
             </a:r>
           </a:p>
         </p:txBody>
@@ -16704,7 +16556,7 @@
                   <a:srgbClr val="0D3B66"/>
                 </a:solidFill>
               </a:rPr>
-              <a:t>policy_*.h</a:t>
+              <a:t>policy_mlp.h</a:t>
             </a:r>
           </a:p>
           <a:p>
@@ -16737,7 +16589,7 @@
                   <a:srgbClr val="0D3B66"/>
                 </a:solidFill>
               </a:rPr>
-              <a:t>773 KB MLP / 496 KB Cartan</a:t>
+              <a:t>773 KB MLP</a:t>
             </a:r>
           </a:p>
         </p:txBody>
@@ -16812,7 +16664,7 @@
                   <a:srgbClr val="0D3B66"/>
                 </a:solidFill>
               </a:rPr>
-              <a:t>expf/logf, no heap</a:t>
+              <a:t>expf, no heap</a:t>
             </a:r>
           </a:p>
           <a:p>
@@ -17038,7 +16890,7 @@
                   <a:srgbClr val="555555"/>
                 </a:solidFill>
               </a:rPr>
-              <a:t>tools/export_*_c.py</a:t>
+              <a:t>tools/export_policy_c.py</a:t>
             </a:r>
           </a:p>
         </p:txBody>
@@ -17193,7 +17045,7 @@
             </a:pPr>
             <a:r>
               <a:rPr sz="1200" b="0"/>
-              <a:t>•  tools/parity_check.py: 2201 observations → ONNX Runtime vs the C binary: max 3.8e-6 (MLP), 6.0e-5 (Cartan)</a:t>
+              <a:t>•  tools/parity_check.py: 2201 observations → ONNX Runtime vs the C binary: max 3.8e-6 (MLP)</a:t>
             </a:r>
           </a:p>
           <a:p>
@@ -17230,7 +17082,7 @@
                   <a:srgbClr val="0D3B66"/>
                 </a:solidFill>
               </a:rPr>
-              <a:t>The two networks (MDK_POLICY)</a:t>
+              <a:t>The network (MDK_POLICY)</a:t>
             </a:r>
           </a:p>
           <a:p>
@@ -17242,17 +17094,6 @@
             <a:r>
               <a:rPr sz="1200" b="0"/>
               <a:t>•  0 = MLP 61→512→256→128→14 ELU, 197 896 parameters, 0.37 ms</a:t>
-            </a:r>
-          </a:p>
-          <a:p>
-            <a:pPr algn="l">
-              <a:spcBef>
-                <a:spcPts val="300"/>
-              </a:spcBef>
-            </a:pPr>
-            <a:r>
-              <a:rPr sz="1200" b="0"/>
-              <a:t>•  1 = Cartan+DiLU 61→192→3×CartanLinear→14, 127 054 parameters (−36 %), 0.25 ms, exp/log operator in C</a:t>
             </a:r>
           </a:p>
         </p:txBody>

</xml_diff>

<commit_message>
Rename the MicroDuck policy task to NNMixer across firmware and docs.
Keep the Cartan copy repo unchanged; this tree now documents and
exposes only AP_NNMixer with NNM_ parameters.

Co-authored-by: Cursor <cursoragent@cursor.com>
</commit_message>
<xml_diff>
--- a/docs/architecture-integration.pptx
+++ b/docs/architecture-integration.pptx
@@ -3127,7 +3127,7 @@
                   <a:srgbClr val="0D3B66"/>
                 </a:solidFill>
               </a:rPr>
-              <a:t>MicroDuck on ArduPilot</a:t>
+              <a:t>NNMixer on ArduPilot</a:t>
             </a:r>
           </a:p>
           <a:p>
@@ -3372,7 +3372,7 @@
                   <a:srgbClr val="555555"/>
                 </a:solidFill>
               </a:rPr>
-              <a:t>Only the third process: the MuJoCo plant becomes the robot. AP_MicroDuck does not change.</a:t>
+              <a:t>Only the third process: the MuJoCo plant becomes the robot. AP_NNMixer does not change.</a:t>
             </a:r>
           </a:p>
         </p:txBody>
@@ -4190,7 +4190,7 @@
             </a:pPr>
             <a:r>
               <a:rPr sz="1200" b="0"/>
-              <a:t>•  param set MDK_POLICY 0 · param set MDK_ENABLE 1</a:t>
+              <a:t>•  param set NNM_POLICY 0 · param set NNM_ENABLE 1</a:t>
             </a:r>
           </a:p>
           <a:p>
@@ -4958,7 +4958,7 @@
                   <a:srgbClr val="2E7D32"/>
                 </a:solidFill>
               </a:rPr>
-              <a:t>param set MDK_*</a:t>
+              <a:t>param set NNM_*</a:t>
             </a:r>
           </a:p>
           <a:p>
@@ -5077,7 +5077,7 @@
                   <a:srgbClr val="0D3B66"/>
                 </a:solidFill>
               </a:rPr>
-              <a:t>AP_MicroDuck: PPO network 50 Hz</a:t>
+              <a:t>AP_NNMixer: PPO network 50 Hz</a:t>
             </a:r>
           </a:p>
           <a:p>
@@ -5544,7 +5544,7 @@
                   <a:srgbClr val="D62728"/>
                 </a:solidFill>
               </a:rPr>
-              <a:t>The PPO task has no link to MuJoCo: it only sees ArduPilot APIs. Replacing the plant with a real IMU + Dynamixel bus does not change a line of AP_MicroDuck.</a:t>
+              <a:t>The PPO task has no link to MuJoCo: it only sees ArduPilot APIs. Replacing the plant with a real IMU + Dynamixel bus does not change a line of AP_NNMixer.</a:t>
             </a:r>
           </a:p>
         </p:txBody>
@@ -5596,7 +5596,7 @@
                   <a:srgbClr val="0D3B66"/>
                 </a:solidFill>
               </a:rPr>
-              <a:t>2. Inside ArduRover: the 50 Hz loop of AP_MicroDuck</a:t>
+              <a:t>2. Inside ArduRover: the 50 Hz loop of AP_NNMixer</a:t>
             </a:r>
           </a:p>
         </p:txBody>
@@ -6684,7 +6684,7 @@
             </a:pPr>
             <a:r>
               <a:rPr sz="1200" b="0"/>
-              <a:t>•  update_attitude() at loop rate: propagates the gravity direction with the gyro, corrects it with the accelerometer (MDK_ATT_TAU 0.5 s)</a:t>
+              <a:t>•  update_attitude() at loop rate: propagates the gravity direction with the gyro, corrects it with the accelerometer (NNM_ATT_TAU 0.5 s)</a:t>
             </a:r>
           </a:p>
           <a:p>
@@ -6706,7 +6706,7 @@
             </a:pPr>
             <a:r>
               <a:rPr sz="1200" b="0"/>
-              <a:t>•  Failsafe: disarmed, joint feedback missing or older than MDK_WD_MS → action 0 = stand pose (also in the history)</a:t>
+              <a:t>•  Failsafe: disarmed, joint feedback missing or older than NNM_WD_MS → action 0 = stand pose (also in the history)</a:t>
             </a:r>
           </a:p>
           <a:p>
@@ -6717,7 +6717,7 @@
             </a:pPr>
             <a:r>
               <a:rPr sz="1200" b="0"/>
-              <a:t>•  HOLD (MDK_HOLD_MODE 4) → twist 0</a:t>
+              <a:t>•  HOLD (NNM_HOLD_MODE 4) → twist 0</a:t>
             </a:r>
           </a:p>
           <a:p>
@@ -7228,7 +7228,7 @@
                   <a:srgbClr val="0D3B66"/>
                 </a:solidFill>
               </a:rPr>
-              <a:t>AP_MicroDuck</a:t>
+              <a:t>AP_NNMixer</a:t>
             </a:r>
           </a:p>
           <a:p>
@@ -7942,7 +7942,7 @@
                             <a:srgbClr val="202020"/>
                           </a:solidFill>
                         </a:rPr>
-                        <a:t>obs[48] vx = +1.0 × MDK_VX_MAX = 0.4 m/s</a:t>
+                        <a:t>obs[48] vx = +1.0 × NNM_VX_MAX = 0.4 m/s</a:t>
                       </a:r>
                     </a:p>
                   </a:txBody>
@@ -8200,7 +8200,7 @@
                             <a:srgbClr val="202020"/>
                           </a:solidFill>
                         </a:rPr>
-                        <a:t>MDK_HOLD_MODE → twist forced to 0: stands still</a:t>
+                        <a:t>NNM_HOLD_MODE → twist forced to 0: stands still</a:t>
                       </a:r>
                     </a:p>
                   </a:txBody>
@@ -8223,7 +8223,7 @@
                             <a:srgbClr val="202020"/>
                           </a:solidFill>
                         </a:rPr>
-                        <a:t>param set MDK_POLICY 0</a:t>
+                        <a:t>param set NNM_POLICY 0</a:t>
                       </a:r>
                     </a:p>
                   </a:txBody>
@@ -8423,7 +8423,7 @@
             </a:pPr>
             <a:r>
               <a:rPr sz="1300" b="0"/>
-              <a:t>DataFlash log MDK / MDKQ / MDKV / MDKA: every tick with the 61 observations and 14 actions → tools/log_parity.py replays them through the ONNX (parity 2.5e-7).</a:t>
+              <a:t>DataFlash log NNM / NNMQ / NNMV / NNMA: every tick with the 61 observations and 14 actions → tools/log_parity.py replays them through the ONNX (parity 2.5e-7).</a:t>
             </a:r>
           </a:p>
         </p:txBody>
@@ -8687,7 +8687,7 @@
                   <a:srgbClr val="0D3B66"/>
                 </a:solidFill>
               </a:rPr>
-              <a:t>clip ±MDK_ACT_MAX</a:t>
+              <a:t>clip ±NNM_ACT_MAX</a:t>
             </a:r>
           </a:p>
         </p:txBody>
@@ -9392,7 +9392,7 @@
                             <a:srgbClr val="202020"/>
                           </a:solidFill>
                         </a:rPr>
-                        <a:t>libraries/AP_MicroDuck/  (new)</a:t>
+                        <a:t>libraries/AP_NNMixer/  (new)</a:t>
                       </a:r>
                     </a:p>
                   </a:txBody>
@@ -9413,7 +9413,7 @@
                             <a:srgbClr val="202020"/>
                           </a:solidFill>
                         </a:rPr>
-                        <a:t>AP_MicroDuck.{h,cpp}, microduck_infer.{h,c}, policy_mlp.h, AP_MicroDuck_config.h</a:t>
+                        <a:t>AP_NNMixer.{h,cpp}, nnmixer_infer.{h,c}, policy_mlp.h, AP_NNMixer_config.h</a:t>
                       </a:r>
                     </a:p>
                   </a:txBody>
@@ -9434,7 +9434,7 @@
                             <a:srgbClr val="202020"/>
                           </a:solidFill>
                         </a:rPr>
-                        <a:t>the task: obs, gravity filter, history, sticks, servos, MDK_*, log, telemetry; network in C</a:t>
+                        <a:t>the task: obs, gravity filter, history, sticks, servos, NNM_*, log, telemetry; network in C</a:t>
                       </a:r>
                     </a:p>
                   </a:txBody>
@@ -9478,7 +9478,7 @@
                             <a:srgbClr val="202020"/>
                           </a:solidFill>
                         </a:rPr>
-                        <a:t>member g2.microduck; AP_SUBGROUPINFO "MDK_" index 63</a:t>
+                        <a:t>member g2.nnmixer; AP_SUBGROUPINFO "NNM_" index 63</a:t>
                       </a:r>
                     </a:p>
                   </a:txBody>
@@ -9499,7 +9499,7 @@
                             <a:srgbClr val="202020"/>
                           </a:solidFill>
                         </a:rPr>
-                        <a:t>MDK_* parameters visible from the GCS and stored in EEPROM</a:t>
+                        <a:t>NNM_* parameters visible from the GCS and stored in EEPROM</a:t>
                       </a:r>
                     </a:p>
                   </a:txBody>
@@ -9608,7 +9608,7 @@
                             <a:srgbClr val="202020"/>
                           </a:solidFill>
                         </a:rPr>
-                        <a:t>+ 'AP_MicroDuck'</a:t>
+                        <a:t>+ 'AP_NNMixer'</a:t>
                       </a:r>
                     </a:p>
                   </a:txBody>
@@ -9799,7 +9799,7 @@
             <a:pPr algn="l"/>
             <a:r>
               <a:rPr sz="1300" b="0"/>
-              <a:t>No change to RC_Channels, SRV_Channel, AP_InertialSensor, AP_Arming, GCS_MAVLink: the task uses their public APIs. AP_MICRODUCK_ENABLED is 1 on SITL; boards must opt in (weights ~770 KB of flash as float32).</a:t>
+              <a:t>No change to RC_Channels, SRV_Channel, AP_InertialSensor, AP_Arming, GCS_MAVLink: the task uses their public APIs. AP_NNMIXER_ENABLED is 1 on SITL; boards must opt in (weights ~770 KB of flash as float32).</a:t>
             </a:r>
           </a:p>
           <a:p>
@@ -9810,7 +9810,7 @@
             </a:pPr>
             <a:r>
               <a:rPr sz="1300" b="0"/>
-              <a:t>SITL parameters (sitl/microduck.parm): SERVO1..14_FUNCTION 94..107, SERVOn_MIN/MAX 800/2200, SIM_RATE_HZ 200, SCHED_LOOP_RATE 200, INS_GYRO_FILTER 0, ARMING_CHECK 0, MDK_ENABLE 1.</a:t>
+              <a:t>SITL parameters (sitl/nnmixer.parm): SERVO1..14_FUNCTION 94..107, SERVOn_MIN/MAX 800/2200, SIM_RATE_HZ 200, SCHED_LOOP_RATE 200, INS_GYRO_FILTER 0, ARMING_CHECK 0, NNM_ENABLE 1.</a:t>
             </a:r>
           </a:p>
         </p:txBody>
@@ -15400,7 +15400,7 @@
                   <a:srgbClr val="2E7D32"/>
                 </a:solidFill>
               </a:rPr>
-              <a:t>AP_MicroDuck::update  (20 ms)</a:t>
+              <a:t>AP_NNMixer::update  (20 ms)</a:t>
             </a:r>
           </a:p>
         </p:txBody>
@@ -16642,7 +16642,7 @@
                   <a:srgbClr val="0D3B66"/>
                 </a:solidFill>
               </a:rPr>
-              <a:t>microduck_infer.c</a:t>
+              <a:t>nnmixer_infer.c</a:t>
             </a:r>
           </a:p>
           <a:p>
@@ -16728,7 +16728,7 @@
                   <a:srgbClr val="0D3B66"/>
                 </a:solidFill>
               </a:rPr>
-              <a:t>AP_MicroDuck</a:t>
+              <a:t>AP_NNMixer</a:t>
             </a:r>
           </a:p>
           <a:p>
@@ -17082,7 +17082,7 @@
                   <a:srgbClr val="0D3B66"/>
                 </a:solidFill>
               </a:rPr>
-              <a:t>The network (MDK_POLICY)</a:t>
+              <a:t>The network (NNM_POLICY)</a:t>
             </a:r>
           </a:p>
           <a:p>

</xml_diff>